<commit_message>
Implement Product 1 sub-modules: Sales, Credit, Accounting, Communications
Replace all 4 placeholder pages with full CRUD modules:

- modules/sales.py: Territory-based sales contracts, collection tracking
  with due/received/overdue status, variance analysis, payment recording
- modules/credit.py: AI-powered counterparty credit scoring (AAA-CCC tiers),
  payment reliability, risk factors via Grok analysis
- modules/accounting.py: Transaction ledger (disbursement/repayment/fee/interest),
  multi-currency, net position tracking, counterparty linking
- modules/comms.py: Deal-linked messages/tasks with due dates, HTMX checkbox
  toggle for task completion, overdue flagging

Also: 4 new agent tools + chat commands (sales:list, credit:CONTACT,
transactions, messages), updated user guide with 4 new sections,
regenerated screenshots and PPTX.

Co-Authored-By: Claude Opus 4.6 (1M context) <noreply@anthropic.com>
</commit_message>
<xml_diff>
--- a/docs/AHMF_Platform_Overview.pptx
+++ b/docs/AHMF_Platform_Overview.pptx
@@ -3513,7 +3513,7 @@
         <p:spPr>
           <a:xfrm>
             <a:off x="6217920" y="1188720"/>
-            <a:ext cx="5303520" cy="5162989"/>
+            <a:ext cx="5303520" cy="3729038"/>
           </a:xfrm>
           <a:prstGeom prst="rect">
             <a:avLst/>
@@ -3818,7 +3818,7 @@
         <p:spPr>
           <a:xfrm>
             <a:off x="6217920" y="1188720"/>
-            <a:ext cx="5303520" cy="5162989"/>
+            <a:ext cx="5303520" cy="3729038"/>
           </a:xfrm>
           <a:prstGeom prst="rect">
             <a:avLst/>
@@ -4482,7 +4482,7 @@
         <p:spPr>
           <a:xfrm>
             <a:off x="6217920" y="1188720"/>
-            <a:ext cx="5303520" cy="5162989"/>
+            <a:ext cx="5303520" cy="3729038"/>
           </a:xfrm>
           <a:prstGeom prst="rect">
             <a:avLst/>
@@ -5473,7 +5473,7 @@
         <p:spPr>
           <a:xfrm>
             <a:off x="6217920" y="1188720"/>
-            <a:ext cx="5303520" cy="5162989"/>
+            <a:ext cx="5303520" cy="3729038"/>
           </a:xfrm>
           <a:prstGeom prst="rect">
             <a:avLst/>
@@ -5790,7 +5790,7 @@
         <p:spPr>
           <a:xfrm>
             <a:off x="6217920" y="1188720"/>
-            <a:ext cx="5303520" cy="5162989"/>
+            <a:ext cx="5303520" cy="3729038"/>
           </a:xfrm>
           <a:prstGeom prst="rect">
             <a:avLst/>
@@ -6065,7 +6065,7 @@
         <p:spPr>
           <a:xfrm>
             <a:off x="6217920" y="1188720"/>
-            <a:ext cx="5303520" cy="5162989"/>
+            <a:ext cx="5303520" cy="3729038"/>
           </a:xfrm>
           <a:prstGeom prst="rect">
             <a:avLst/>
@@ -6355,7 +6355,7 @@
         <p:spPr>
           <a:xfrm>
             <a:off x="6217920" y="1188720"/>
-            <a:ext cx="5303520" cy="5162989"/>
+            <a:ext cx="5303520" cy="3729038"/>
           </a:xfrm>
           <a:prstGeom prst="rect">
             <a:avLst/>
@@ -6687,7 +6687,7 @@
         <p:spPr>
           <a:xfrm>
             <a:off x="6217920" y="1188720"/>
-            <a:ext cx="5303520" cy="5162989"/>
+            <a:ext cx="5303520" cy="3729038"/>
           </a:xfrm>
           <a:prstGeom prst="rect">
             <a:avLst/>
@@ -7034,7 +7034,7 @@
         <p:spPr>
           <a:xfrm>
             <a:off x="6217920" y="1188720"/>
-            <a:ext cx="5303520" cy="5162989"/>
+            <a:ext cx="5303520" cy="3729038"/>
           </a:xfrm>
           <a:prstGeom prst="rect">
             <a:avLst/>
@@ -7339,7 +7339,7 @@
         <p:spPr>
           <a:xfrm>
             <a:off x="6217920" y="1188720"/>
-            <a:ext cx="5303520" cy="5162989"/>
+            <a:ext cx="5303520" cy="3729038"/>
           </a:xfrm>
           <a:prstGeom prst="rect">
             <a:avLst/>

</xml_diff>